<commit_message>
Rediseña figura de estrategias cruzadas DOFA para mayor legibilidad
</commit_message>
<xml_diff>
--- a/DOFA-CIE.pptx
+++ b/DOFA-CIE.pptx
@@ -9230,8 +9230,8 @@
         </p:blipFill>
         <p:spPr>
           <a:xfrm>
-            <a:off x="6646580" y="3657600"/>
-            <a:ext cx="11093887" cy="7863840"/>
+            <a:off x="7795581" y="3657600"/>
+            <a:ext cx="8795886" cy="7863840"/>
           </a:xfrm>
           <a:prstGeom prst="rect">
             <a:avLst/>

</xml_diff>